<commit_message>
Align pitch opening with website hero message
</commit_message>
<xml_diff>
--- a/outputs/Folio-Website-Pitch.pptx
+++ b/outputs/Folio-Website-Pitch.pptx
@@ -2,20 +2,20 @@
 <file path=ppt/presentation.xml><?xml version="1.0" encoding="utf-8"?>
 <p:presentation xmlns:p="http://schemas.openxmlformats.org/presentationml/2006/main">
   <p:sldMasterIdLst>
-    <p:sldMasterId xmlns:r="http://schemas.openxmlformats.org/officeDocument/2006/relationships" id="2147483648" r:id="Rf91c81a2e8fd4792"/>
+    <p:sldMasterId xmlns:r="http://schemas.openxmlformats.org/officeDocument/2006/relationships" id="2147483648" r:id="Rdb9b0df1a1e74bb5"/>
   </p:sldMasterIdLst>
   <p:notesMasterIdLst>
-    <p:notesMasterId xmlns:r="http://schemas.openxmlformats.org/officeDocument/2006/relationships" r:id="R5bb0841b24754163"/>
+    <p:notesMasterId xmlns:r="http://schemas.openxmlformats.org/officeDocument/2006/relationships" r:id="Ra7f180f1f2694ae3"/>
   </p:notesMasterIdLst>
   <p:sldIdLst>
-    <p:sldId xmlns:r="http://schemas.openxmlformats.org/officeDocument/2006/relationships" id="256" r:id="Reb135dfdc7a24677"/>
-    <p:sldId xmlns:r="http://schemas.openxmlformats.org/officeDocument/2006/relationships" id="257" r:id="Rba2cba245337414f"/>
-    <p:sldId xmlns:r="http://schemas.openxmlformats.org/officeDocument/2006/relationships" id="258" r:id="R39fdaba9b5324580"/>
-    <p:sldId xmlns:r="http://schemas.openxmlformats.org/officeDocument/2006/relationships" id="259" r:id="Rf6f54c91c0484dc8"/>
-    <p:sldId xmlns:r="http://schemas.openxmlformats.org/officeDocument/2006/relationships" id="260" r:id="R7d67cac270ba4474"/>
-    <p:sldId xmlns:r="http://schemas.openxmlformats.org/officeDocument/2006/relationships" id="261" r:id="R9f42ed1b200e4a92"/>
-    <p:sldId xmlns:r="http://schemas.openxmlformats.org/officeDocument/2006/relationships" id="262" r:id="R737ecb21dad546b3"/>
-    <p:sldId xmlns:r="http://schemas.openxmlformats.org/officeDocument/2006/relationships" id="263" r:id="Rde254e2c915b4274"/>
+    <p:sldId xmlns:r="http://schemas.openxmlformats.org/officeDocument/2006/relationships" id="256" r:id="R9dc4b3854d0544e4"/>
+    <p:sldId xmlns:r="http://schemas.openxmlformats.org/officeDocument/2006/relationships" id="257" r:id="Rda32efa5156f426c"/>
+    <p:sldId xmlns:r="http://schemas.openxmlformats.org/officeDocument/2006/relationships" id="258" r:id="R504be207955d4610"/>
+    <p:sldId xmlns:r="http://schemas.openxmlformats.org/officeDocument/2006/relationships" id="259" r:id="Rc8c88dc929c5461c"/>
+    <p:sldId xmlns:r="http://schemas.openxmlformats.org/officeDocument/2006/relationships" id="260" r:id="R2d5eb80eef684891"/>
+    <p:sldId xmlns:r="http://schemas.openxmlformats.org/officeDocument/2006/relationships" id="261" r:id="R3c373a7eebd54b3d"/>
+    <p:sldId xmlns:r="http://schemas.openxmlformats.org/officeDocument/2006/relationships" id="262" r:id="Rf85967b1aba84577"/>
+    <p:sldId xmlns:r="http://schemas.openxmlformats.org/officeDocument/2006/relationships" id="263" r:id="R8e4b8e88616346e8"/>
   </p:sldIdLst>
   <p:sldSz cx="12192000" cy="6858000"/>
   <p:notesSz cx="6858000" cy="9144000"/>
@@ -449,12 +449,12 @@
           <a:lstStyle xmlns:a="http://schemas.openxmlformats.org/drawingml/2006/main"/>
           <a:p xmlns:a="http://schemas.openxmlformats.org/drawingml/2006/main">
             <a:r>
-              <a:t>See the risk before it reaches your portfolio.</a:t>
-            </a:r>
-          </a:p>
-          <a:p xmlns:a="http://schemas.openxmlformats.org/drawingml/2006/main">
-            <a:r>
-              <a:t>{"label":"Problem &amp; solution","title":"See the risk before it reaches your portfolio.","accent":"Your money. In perspective.","body":["Rates change. Inflation surprises. Your investments react.","Folio shows what could happen next and what it could mean for your money."],"note":"News + economic data → possible events → your portfolio"}</a:t>
+              <a:t>Anticipate market moves. Protect your portfolio.</a:t>
+            </a:r>
+          </a:p>
+          <a:p xmlns:a="http://schemas.openxmlformats.org/drawingml/2006/main">
+            <a:r>
+              <a:t>{"label":"A new perspective on your portfolio","title":"Anticipate market moves. Protect your portfolio.","body":["Spot macro risks early. See what’s at stake for your portfolio before you act."],"note":"Live macro evidence · Your portfolio stays private"}</a:t>
             </a:r>
           </a:p>
           <a:p xmlns:a="http://schemas.openxmlformats.org/drawingml/2006/main">
@@ -1087,7 +1087,7 @@
   </p:cSld>
   <p:clrMap bg1="lt1" tx1="dk1" bg2="lt2" tx2="dk2" accent1="accent1" accent2="accent2" accent3="accent3" accent4="accent4" accent5="accent5" accent6="accent6" hlink="hlink" folHlink="folHlink"/>
   <p:sldLayoutIdLst>
-    <p:sldLayoutId xmlns:r="http://schemas.openxmlformats.org/officeDocument/2006/relationships" id="2147483649" r:id="Re0574bdcbeb54bb4"/>
+    <p:sldLayoutId xmlns:r="http://schemas.openxmlformats.org/officeDocument/2006/relationships" id="2147483649" r:id="R33a943175c0e44dc"/>
   </p:sldLayoutIdLst>
   <p:txStyles>
     <p:titleStyle>
@@ -1635,7 +1635,7 @@
           <p:nvPr/>
         </p:nvPicPr>
         <p:blipFill>
-          <a:blip xmlns:r="http://schemas.openxmlformats.org/officeDocument/2006/relationships" xmlns:a="http://schemas.openxmlformats.org/drawingml/2006/main" r:embed="R81813697e8754679"/>
+          <a:blip xmlns:r="http://schemas.openxmlformats.org/officeDocument/2006/relationships" xmlns:a="http://schemas.openxmlformats.org/drawingml/2006/main" r:embed="R72d8e2ecbd8340ff"/>
           <a:stretch xmlns:a="http://schemas.openxmlformats.org/drawingml/2006/main"/>
         </p:blipFill>
         <p:spPr>
@@ -1651,7 +1651,7 @@
     </p:spTree>
     <p:extLst>
       <p:ext uri="{BB962C8B-B14F-4D97-AF65-F5344CB8AC3E}">
-        <p14:creationId xmlns:p14="http://schemas.microsoft.com/office/powerpoint/2010/main" val="1391841900"/>
+        <p14:creationId xmlns:p14="http://schemas.microsoft.com/office/powerpoint/2010/main" val="1929788340"/>
       </p:ext>
     </p:extLst>
   </p:cSld>
@@ -1679,7 +1679,7 @@
           <p:nvPr/>
         </p:nvPicPr>
         <p:blipFill>
-          <a:blip xmlns:r="http://schemas.openxmlformats.org/officeDocument/2006/relationships" xmlns:a="http://schemas.openxmlformats.org/drawingml/2006/main" r:embed="R7d893f9f5cef4eb6"/>
+          <a:blip xmlns:r="http://schemas.openxmlformats.org/officeDocument/2006/relationships" xmlns:a="http://schemas.openxmlformats.org/drawingml/2006/main" r:embed="R559c69431c044e0f"/>
           <a:stretch xmlns:a="http://schemas.openxmlformats.org/drawingml/2006/main"/>
         </p:blipFill>
         <p:spPr>
@@ -1695,7 +1695,7 @@
     </p:spTree>
     <p:extLst>
       <p:ext uri="{BB962C8B-B14F-4D97-AF65-F5344CB8AC3E}">
-        <p14:creationId xmlns:p14="http://schemas.microsoft.com/office/powerpoint/2010/main" val="480383080"/>
+        <p14:creationId xmlns:p14="http://schemas.microsoft.com/office/powerpoint/2010/main" val="670824829"/>
       </p:ext>
     </p:extLst>
   </p:cSld>
@@ -1723,7 +1723,7 @@
           <p:nvPr/>
         </p:nvPicPr>
         <p:blipFill>
-          <a:blip xmlns:r="http://schemas.openxmlformats.org/officeDocument/2006/relationships" xmlns:a="http://schemas.openxmlformats.org/drawingml/2006/main" r:embed="R03487c3df5fc41c9"/>
+          <a:blip xmlns:r="http://schemas.openxmlformats.org/officeDocument/2006/relationships" xmlns:a="http://schemas.openxmlformats.org/drawingml/2006/main" r:embed="R5d9c53fa16db4fd9"/>
           <a:stretch xmlns:a="http://schemas.openxmlformats.org/drawingml/2006/main"/>
         </p:blipFill>
         <p:spPr>
@@ -1739,7 +1739,7 @@
     </p:spTree>
     <p:extLst>
       <p:ext uri="{BB962C8B-B14F-4D97-AF65-F5344CB8AC3E}">
-        <p14:creationId xmlns:p14="http://schemas.microsoft.com/office/powerpoint/2010/main" val="1156104724"/>
+        <p14:creationId xmlns:p14="http://schemas.microsoft.com/office/powerpoint/2010/main" val="1329520438"/>
       </p:ext>
     </p:extLst>
   </p:cSld>
@@ -1767,7 +1767,7 @@
           <p:nvPr/>
         </p:nvPicPr>
         <p:blipFill>
-          <a:blip xmlns:r="http://schemas.openxmlformats.org/officeDocument/2006/relationships" xmlns:a="http://schemas.openxmlformats.org/drawingml/2006/main" r:embed="R9f809c8dcf4341c7"/>
+          <a:blip xmlns:r="http://schemas.openxmlformats.org/officeDocument/2006/relationships" xmlns:a="http://schemas.openxmlformats.org/drawingml/2006/main" r:embed="R2c097ac3ab7642ca"/>
           <a:stretch xmlns:a="http://schemas.openxmlformats.org/drawingml/2006/main"/>
         </p:blipFill>
         <p:spPr>
@@ -1783,7 +1783,7 @@
     </p:spTree>
     <p:extLst>
       <p:ext uri="{BB962C8B-B14F-4D97-AF65-F5344CB8AC3E}">
-        <p14:creationId xmlns:p14="http://schemas.microsoft.com/office/powerpoint/2010/main" val="1374734354"/>
+        <p14:creationId xmlns:p14="http://schemas.microsoft.com/office/powerpoint/2010/main" val="1343900273"/>
       </p:ext>
     </p:extLst>
   </p:cSld>
@@ -1811,7 +1811,7 @@
           <p:nvPr/>
         </p:nvPicPr>
         <p:blipFill>
-          <a:blip xmlns:r="http://schemas.openxmlformats.org/officeDocument/2006/relationships" xmlns:a="http://schemas.openxmlformats.org/drawingml/2006/main" r:embed="Rb07933d7490e4ce9"/>
+          <a:blip xmlns:r="http://schemas.openxmlformats.org/officeDocument/2006/relationships" xmlns:a="http://schemas.openxmlformats.org/drawingml/2006/main" r:embed="R6fcf5edab3d84d6c"/>
           <a:stretch xmlns:a="http://schemas.openxmlformats.org/drawingml/2006/main"/>
         </p:blipFill>
         <p:spPr>
@@ -1827,7 +1827,7 @@
     </p:spTree>
     <p:extLst>
       <p:ext uri="{BB962C8B-B14F-4D97-AF65-F5344CB8AC3E}">
-        <p14:creationId xmlns:p14="http://schemas.microsoft.com/office/powerpoint/2010/main" val="648638311"/>
+        <p14:creationId xmlns:p14="http://schemas.microsoft.com/office/powerpoint/2010/main" val="924003408"/>
       </p:ext>
     </p:extLst>
   </p:cSld>
@@ -1855,7 +1855,7 @@
           <p:nvPr/>
         </p:nvPicPr>
         <p:blipFill>
-          <a:blip xmlns:r="http://schemas.openxmlformats.org/officeDocument/2006/relationships" xmlns:a="http://schemas.openxmlformats.org/drawingml/2006/main" r:embed="R909518d4002f438c"/>
+          <a:blip xmlns:r="http://schemas.openxmlformats.org/officeDocument/2006/relationships" xmlns:a="http://schemas.openxmlformats.org/drawingml/2006/main" r:embed="R97b9310562f44f3f"/>
           <a:stretch xmlns:a="http://schemas.openxmlformats.org/drawingml/2006/main"/>
         </p:blipFill>
         <p:spPr>
@@ -1871,7 +1871,7 @@
     </p:spTree>
     <p:extLst>
       <p:ext uri="{BB962C8B-B14F-4D97-AF65-F5344CB8AC3E}">
-        <p14:creationId xmlns:p14="http://schemas.microsoft.com/office/powerpoint/2010/main" val="372219074"/>
+        <p14:creationId xmlns:p14="http://schemas.microsoft.com/office/powerpoint/2010/main" val="216741079"/>
       </p:ext>
     </p:extLst>
   </p:cSld>
@@ -1899,7 +1899,7 @@
           <p:nvPr/>
         </p:nvPicPr>
         <p:blipFill>
-          <a:blip xmlns:r="http://schemas.openxmlformats.org/officeDocument/2006/relationships" xmlns:a="http://schemas.openxmlformats.org/drawingml/2006/main" r:embed="R7d9012077625450e"/>
+          <a:blip xmlns:r="http://schemas.openxmlformats.org/officeDocument/2006/relationships" xmlns:a="http://schemas.openxmlformats.org/drawingml/2006/main" r:embed="Rd557913574ff410e"/>
           <a:stretch xmlns:a="http://schemas.openxmlformats.org/drawingml/2006/main"/>
         </p:blipFill>
         <p:spPr>
@@ -1915,7 +1915,7 @@
     </p:spTree>
     <p:extLst>
       <p:ext uri="{BB962C8B-B14F-4D97-AF65-F5344CB8AC3E}">
-        <p14:creationId xmlns:p14="http://schemas.microsoft.com/office/powerpoint/2010/main" val="374107981"/>
+        <p14:creationId xmlns:p14="http://schemas.microsoft.com/office/powerpoint/2010/main" val="788908585"/>
       </p:ext>
     </p:extLst>
   </p:cSld>
@@ -1943,7 +1943,7 @@
           <p:nvPr/>
         </p:nvPicPr>
         <p:blipFill>
-          <a:blip xmlns:r="http://schemas.openxmlformats.org/officeDocument/2006/relationships" xmlns:a="http://schemas.openxmlformats.org/drawingml/2006/main" r:embed="Rbee3759055c94270"/>
+          <a:blip xmlns:r="http://schemas.openxmlformats.org/officeDocument/2006/relationships" xmlns:a="http://schemas.openxmlformats.org/drawingml/2006/main" r:embed="R0e6a7298480c4b7a"/>
           <a:stretch xmlns:a="http://schemas.openxmlformats.org/drawingml/2006/main"/>
         </p:blipFill>
         <p:spPr>
@@ -1959,7 +1959,7 @@
     </p:spTree>
     <p:extLst>
       <p:ext uri="{BB962C8B-B14F-4D97-AF65-F5344CB8AC3E}">
-        <p14:creationId xmlns:p14="http://schemas.microsoft.com/office/powerpoint/2010/main" val="368514090"/>
+        <p14:creationId xmlns:p14="http://schemas.microsoft.com/office/powerpoint/2010/main" val="1175050443"/>
       </p:ext>
     </p:extLst>
   </p:cSld>

</xml_diff>